<commit_message>
Rebuild report on exact PTIT template, restore math and audit slides and data lineage
</commit_message>
<xml_diff>
--- a/reports/presentation_final/Slide_thuyet_trinh_TPOUR_TRPO_cap_nhat.pptx
+++ b/reports/presentation_final/Slide_thuyet_trinh_TPOUR_TRPO_cap_nhat.pptx
@@ -8,6 +8,8 @@
     <p:sldId id="256" r:id="rId7"/>
     <p:sldId id="257" r:id="rId9"/>
     <p:sldId id="258" r:id="rId10"/>
+    <p:sldId id="279" r:id="rId31"/>
+    <p:sldId id="280" r:id="rId32"/>
     <p:sldId id="259" r:id="rId11"/>
     <p:sldId id="260" r:id="rId12"/>
     <p:sldId id="261" r:id="rId13"/>
@@ -27,6 +29,8 @@
     <p:sldId id="275" r:id="rId27"/>
     <p:sldId id="276" r:id="rId28"/>
     <p:sldId id="277" r:id="rId29"/>
+    <p:sldId id="281" r:id="rId33"/>
+    <p:sldId id="282" r:id="rId34"/>
     <p:sldId id="278" r:id="rId30"/>
   </p:sldIdLst>
   <p:sldSz cx="12191695" cy="6858000" type="screen4x3"/>
@@ -524,7 +528,7 @@
           <a:lstStyle/>
           <a:p>
             <a:r>
-              <a:t>Mở đầu: Nhóm tìm hiểu truy xuất thông tin có yếu tố thời gian. Em trình bày phương pháp của bài báo, phần nhóm đã triển khai và một biến thể giữ kiến thức đã được kiểm chứng. Kết quả có lợi trên SciFact so với TRPO nhưng còn đánh đổi. Thời lượng gợi ý 12–15 phút cho slide 1–19; slide 20–23 dùng khi hỏi.</a:t>
+              <a:t>Mở đầu: Nhóm tìm hiểu truy xuất thông tin có yếu tố thời gian. Em trình bày phương pháp của bài báo, phần nhóm đã triển khai và một biến thể giữ kiến thức đã được kiểm chứng. Kết quả có lợi trên SciFact so với TRPO nhưng còn đánh đổi. Thời lượng gợi ý 12–15 phút cho slide 1–21; slide 22–27 dùng khi hỏi.</a:t>
             </a:r>
           </a:p>
         </p:txBody>
@@ -1574,7 +1578,287 @@
           <a:lstStyle/>
           <a:p>
             <a:r>
-              <a:t>Tài liệu gốc nằm trong repo, cùng PDF đã chọn. Notebook Kaggle có thể cần quyền tài khoản; JSON/log/notebook source công khai trong GitHub cho phép đọc bằng chứng. Slide 1–19 là phần trình bày chính; 20–23 là phụ lục.</a:t>
+              <a:t>Tài liệu gốc nằm trong repo, cùng PDF đã chọn. Notebook Kaggle có thể cần quyền tài khoản; JSON/log/notebook source công khai trong GitHub cho phép đọc bằng chứng. Slide 1–21 là phần trình bày chính; 22–27 là phụ lục.</a:t>
+            </a:r>
+          </a:p>
+        </p:txBody>
+      </p:sp>
+      <p:sp>
+        <p:nvSpPr>
+          <p:cNvPr id="4" name="Slide Number Placeholder 3"/>
+          <p:cNvSpPr>
+            <a:spLocks noGrp="1"/>
+          </p:cNvSpPr>
+          <p:nvPr>
+            <p:ph type="sldNum" idx="5" sz="quarter"/>
+          </p:nvPr>
+        </p:nvSpPr>
+        <p:spPr/>
+      </p:sp>
+    </p:spTree>
+  </p:cSld>
+  <p:clrMapOvr>
+    <a:masterClrMapping/>
+  </p:clrMapOvr>
+</p:notes>
+</file>
+
+<file path=ppt/notesSlides/notesSlide24.xml><?xml version="1.0" encoding="utf-8"?>
+<p:notes xmlns:a="http://schemas.openxmlformats.org/drawingml/2006/main" xmlns:p="http://schemas.openxmlformats.org/presentationml/2006/main" xmlns:r="http://schemas.openxmlformats.org/officeDocument/2006/relationships">
+  <p:cSld>
+    <p:spTree>
+      <p:nvGrpSpPr>
+        <p:cNvPr id="1" name=""/>
+        <p:cNvGrpSpPr/>
+        <p:nvPr/>
+      </p:nvGrpSpPr>
+      <p:grpSpPr>
+        <a:xfrm>
+          <a:off x="0" y="0"/>
+          <a:ext cx="0" cy="0"/>
+          <a:chOff x="0" y="0"/>
+          <a:chExt cx="0" cy="0"/>
+        </a:xfrm>
+      </p:grpSpPr>
+      <p:sp>
+        <p:nvSpPr>
+          <p:cNvPr id="2" name="Slide Image Placeholder 1"/>
+          <p:cNvSpPr>
+            <a:spLocks noGrp="1"/>
+          </p:cNvSpPr>
+          <p:nvPr>
+            <p:ph type="sldImg" idx="2"/>
+          </p:nvPr>
+        </p:nvSpPr>
+        <p:spPr/>
+      </p:sp>
+      <p:sp>
+        <p:nvSpPr>
+          <p:cNvPr id="3" name="Notes Placeholder 2"/>
+          <p:cNvSpPr>
+            <a:spLocks noGrp="1"/>
+          </p:cNvSpPr>
+          <p:nvPr>
+            <p:ph type="body" idx="3" sz="quarter"/>
+          </p:nvPr>
+        </p:nvSpPr>
+        <p:spPr/>
+        <p:txBody>
+          <a:bodyPr/>
+          <a:lstStyle/>
+          <a:p>
+            <a:r>
+              <a:t>s là dot product chưa chia nhiệt độ; Δ là chênh lệch score đã chia T. CE hiển thị cho một query, code trung bình theo batch. k_j là negative key reference trong queue. TRPO có reference gap detach và β=0,3, T=0,05. Khi hai gap bằng nhau, loss ln2 nhưng gradient student chưa bằng0. Đây là công thức bản gọn đối chiếu mục3.1, không phải weighted KL hoặc PPO.</a:t>
+            </a:r>
+          </a:p>
+        </p:txBody>
+      </p:sp>
+      <p:sp>
+        <p:nvSpPr>
+          <p:cNvPr id="4" name="Slide Number Placeholder 3"/>
+          <p:cNvSpPr>
+            <a:spLocks noGrp="1"/>
+          </p:cNvSpPr>
+          <p:nvPr>
+            <p:ph type="sldNum" idx="5" sz="quarter"/>
+          </p:nvPr>
+        </p:nvSpPr>
+        <p:spPr/>
+      </p:sp>
+    </p:spTree>
+  </p:cSld>
+  <p:clrMapOvr>
+    <a:masterClrMapping/>
+  </p:clrMapOvr>
+</p:notes>
+</file>
+
+<file path=ppt/notesSlides/notesSlide25.xml><?xml version="1.0" encoding="utf-8"?>
+<p:notes xmlns:a="http://schemas.openxmlformats.org/drawingml/2006/main" xmlns:p="http://schemas.openxmlformats.org/presentationml/2006/main" xmlns:r="http://schemas.openxmlformats.org/officeDocument/2006/relationships">
+  <p:cSld>
+    <p:spTree>
+      <p:nvGrpSpPr>
+        <p:cNvPr id="1" name=""/>
+        <p:cNvGrpSpPr/>
+        <p:nvPr/>
+      </p:nvGrpSpPr>
+      <p:grpSpPr>
+        <a:xfrm>
+          <a:off x="0" y="0"/>
+          <a:ext cx="0" cy="0"/>
+          <a:chOff x="0" y="0"/>
+          <a:chExt cx="0" cy="0"/>
+        </a:xfrm>
+      </p:grpSpPr>
+      <p:sp>
+        <p:nvSpPr>
+          <p:cNvPr id="2" name="Slide Image Placeholder 1"/>
+          <p:cNvSpPr>
+            <a:spLocks noGrp="1"/>
+          </p:cNvSpPr>
+          <p:nvPr>
+            <p:ph type="sldImg" idx="2"/>
+          </p:nvPr>
+        </p:nvSpPr>
+        <p:spPr/>
+      </p:sp>
+      <p:sp>
+        <p:nvSpPr>
+          <p:cNvPr id="3" name="Notes Placeholder 2"/>
+          <p:cNvSpPr>
+            <a:spLocks noGrp="1"/>
+          </p:cNvSpPr>
+          <p:nvPr>
+            <p:ph type="body" idx="3" sz="quarter"/>
+          </p:nvPr>
+        </p:nvSpPr>
+        <p:spPr/>
+        <p:txBody>
+          <a:bodyPr/>
+          <a:lstStyle/>
+          <a:p>
+            <a:r>
+              <a:t>Nội suy trọng số giữa hai encoder chuyên biệt thời gian cùng nền, không phải chèn year embedding vào query. Hai checkpoint toy từng nội suy chỉ là kiểm tra thao tác tensor, không đại diện 2018 và2021. Điều kiện là cùng kiến trúc, pretrained base, tokenizer và metadata tương thích. Phải mã hóa lại corpus sau khi đổi encoder; nhóm chưa kiểm chứng chất lượng nội suy trên temporal gold.</a:t>
+            </a:r>
+          </a:p>
+        </p:txBody>
+      </p:sp>
+      <p:sp>
+        <p:nvSpPr>
+          <p:cNvPr id="4" name="Slide Number Placeholder 3"/>
+          <p:cNvSpPr>
+            <a:spLocks noGrp="1"/>
+          </p:cNvSpPr>
+          <p:nvPr>
+            <p:ph type="sldNum" idx="5" sz="quarter"/>
+          </p:nvPr>
+        </p:nvSpPr>
+        <p:spPr/>
+      </p:sp>
+    </p:spTree>
+  </p:cSld>
+  <p:clrMapOvr>
+    <a:masterClrMapping/>
+  </p:clrMapOvr>
+</p:notes>
+</file>
+
+<file path=ppt/notesSlides/notesSlide26.xml><?xml version="1.0" encoding="utf-8"?>
+<p:notes xmlns:a="http://schemas.openxmlformats.org/drawingml/2006/main" xmlns:p="http://schemas.openxmlformats.org/presentationml/2006/main" xmlns:r="http://schemas.openxmlformats.org/officeDocument/2006/relationships">
+  <p:cSld>
+    <p:spTree>
+      <p:nvGrpSpPr>
+        <p:cNvPr id="1" name=""/>
+        <p:cNvGrpSpPr/>
+        <p:nvPr/>
+      </p:nvGrpSpPr>
+      <p:grpSpPr>
+        <a:xfrm>
+          <a:off x="0" y="0"/>
+          <a:ext cx="0" cy="0"/>
+          <a:chOff x="0" y="0"/>
+          <a:chExt cx="0" cy="0"/>
+        </a:xfrm>
+      </p:grpSpPr>
+      <p:sp>
+        <p:nvSpPr>
+          <p:cNvPr id="2" name="Slide Image Placeholder 1"/>
+          <p:cNvSpPr>
+            <a:spLocks noGrp="1"/>
+          </p:cNvSpPr>
+          <p:nvPr>
+            <p:ph type="sldImg" idx="2"/>
+          </p:nvPr>
+        </p:nvSpPr>
+        <p:spPr/>
+      </p:sp>
+      <p:sp>
+        <p:nvSpPr>
+          <p:cNvPr id="3" name="Notes Placeholder 2"/>
+          <p:cNvSpPr>
+            <a:spLocks noGrp="1"/>
+          </p:cNvSpPr>
+          <p:nvPr>
+            <p:ph type="body" idx="3" sz="quarter"/>
+          </p:nvPr>
+        </p:nvSpPr>
+        <p:spPr/>
+        <p:txBody>
+          <a:bodyPr/>
+          <a:lstStyle/>
+          <a:p>
+            <a:r>
+              <a:t>Đây là công thức chính xác theo anchored_tpour.retention_loss. B query;2B preferred/rejected trong batch;3B embedding gồm query/preferred/rejected. KL(teacher||student) lấy batchmean; MSE tương đối lấy mean3B. Cùng input augmentation, teacher detach. Tr=0,1; epsilon=1e-6. Không có nhãn qrels test hoặc dữ liệu truy xuất ngoài batch đưa vào hai hạng này.</a:t>
+            </a:r>
+          </a:p>
+        </p:txBody>
+      </p:sp>
+      <p:sp>
+        <p:nvSpPr>
+          <p:cNvPr id="4" name="Slide Number Placeholder 3"/>
+          <p:cNvSpPr>
+            <a:spLocks noGrp="1"/>
+          </p:cNvSpPr>
+          <p:nvPr>
+            <p:ph type="sldNum" idx="5" sz="quarter"/>
+          </p:nvPr>
+        </p:nvSpPr>
+        <p:spPr/>
+      </p:sp>
+    </p:spTree>
+  </p:cSld>
+  <p:clrMapOvr>
+    <a:masterClrMapping/>
+  </p:clrMapOvr>
+</p:notes>
+</file>
+
+<file path=ppt/notesSlides/notesSlide27.xml><?xml version="1.0" encoding="utf-8"?>
+<p:notes xmlns:a="http://schemas.openxmlformats.org/drawingml/2006/main" xmlns:p="http://schemas.openxmlformats.org/presentationml/2006/main" xmlns:r="http://schemas.openxmlformats.org/officeDocument/2006/relationships">
+  <p:cSld>
+    <p:spTree>
+      <p:nvGrpSpPr>
+        <p:cNvPr id="1" name=""/>
+        <p:cNvGrpSpPr/>
+        <p:nvPr/>
+      </p:nvGrpSpPr>
+      <p:grpSpPr>
+        <a:xfrm>
+          <a:off x="0" y="0"/>
+          <a:ext cx="0" cy="0"/>
+          <a:chOff x="0" y="0"/>
+          <a:chExt cx="0" cy="0"/>
+        </a:xfrm>
+      </p:grpSpPr>
+      <p:sp>
+        <p:nvSpPr>
+          <p:cNvPr id="2" name="Slide Image Placeholder 1"/>
+          <p:cNvSpPr>
+            <a:spLocks noGrp="1"/>
+          </p:cNvSpPr>
+          <p:nvPr>
+            <p:ph type="sldImg" idx="2"/>
+          </p:nvPr>
+        </p:nvSpPr>
+        <p:spPr/>
+      </p:sp>
+      <p:sp>
+        <p:nvSpPr>
+          <p:cNvPr id="3" name="Notes Placeholder 2"/>
+          <p:cNvSpPr>
+            <a:spLocks noGrp="1"/>
+          </p:cNvSpPr>
+          <p:nvPr>
+            <p:ph type="body" idx="3" sz="quarter"/>
+          </p:nvPr>
+        </p:nvSpPr>
+        <p:spPr/>
+        <p:txBody>
+          <a:bodyPr/>
+          <a:lstStyle/>
+          <a:p>
+            <a:r>
+              <a:t>Rà code và provenance:train đọc train.jsonl xuất từ mẫu tác giả; queue và teacher targets tạo trên cùng dữ liệu đó. SciFact corpus/query/qrels là nguồn đánh giá riêng. Demo chỉ truy xuất corpus SciFact, không gọi web search hay LLM sinh context. Chỉ khẳng định pipeline đã rà soát; chưa thể kiểm toán toàn bộ dữ liệu tiền huấn luyện hoặc mọi trùng ngữ nghĩa. SciFact đã được xem khi thiết kế retention nên vẫn có design bias.</a:t>
             </a:r>
           </a:p>
         </p:txBody>
@@ -5213,18 +5497,10 @@
           </a:bodyPr>
           <a:lstStyle/>
           <a:p>
-            <a:pPr>
-              <a:spcAft>
-                <a:spcPts val="1000"/>
-              </a:spcAft>
-              <a:defRPr sz="1200" b="0">
-                <a:solidFill>
-                  <a:srgbClr val="59636D"/>
-                </a:solidFill>
+            <a:r>
+              <a:rPr sz="1200">
                 <a:latin typeface="Arial"/>
-              </a:defRPr>
-            </a:pPr>
-            <a:r>
+              </a:rPr>
               <a:t>1</a:t>
             </a:r>
           </a:p>
@@ -5350,7 +5626,7 @@
               <a:spcAft>
                 <a:spcPts val="1000"/>
               </a:spcAft>
-              <a:defRPr sz="2200" b="0">
+              <a:defRPr sz="2100" b="0">
                 <a:solidFill>
                   <a:srgbClr val="233E57"/>
                 </a:solidFill>
@@ -5358,7 +5634,7 @@
               </a:defRPr>
             </a:pPr>
             <a:r>
-              <a:t>Mẫu Wikipedia của tác giả · SciFact · Kaggle T4</a:t>
+              <a:t>Nhóm 15 · M25CQHT02-B · Mẫu Wikipedia / SciFact / Kaggle T4</a:t>
             </a:r>
           </a:p>
         </p:txBody>
@@ -5524,19 +5800,11 @@
           </a:bodyPr>
           <a:lstStyle/>
           <a:p>
-            <a:pPr>
-              <a:spcAft>
-                <a:spcPts val="1000"/>
-              </a:spcAft>
-              <a:defRPr sz="1200" b="0">
-                <a:solidFill>
-                  <a:srgbClr val="59636D"/>
-                </a:solidFill>
+            <a:r>
+              <a:rPr sz="1200">
                 <a:latin typeface="Arial"/>
-              </a:defRPr>
-            </a:pPr>
-            <a:r>
-              <a:t>10</a:t>
+              </a:rPr>
+              <a:t>12</a:t>
             </a:r>
           </a:p>
         </p:txBody>
@@ -6028,19 +6296,11 @@
           </a:bodyPr>
           <a:lstStyle/>
           <a:p>
-            <a:pPr>
-              <a:spcAft>
-                <a:spcPts val="1000"/>
-              </a:spcAft>
-              <a:defRPr sz="1200" b="0">
-                <a:solidFill>
-                  <a:srgbClr val="59636D"/>
-                </a:solidFill>
+            <a:r>
+              <a:rPr sz="1200">
                 <a:latin typeface="Arial"/>
-              </a:defRPr>
-            </a:pPr>
-            <a:r>
-              <a:t>11</a:t>
+              </a:rPr>
+              <a:t>13</a:t>
             </a:r>
           </a:p>
         </p:txBody>
@@ -6445,19 +6705,11 @@
           </a:bodyPr>
           <a:lstStyle/>
           <a:p>
-            <a:pPr>
-              <a:spcAft>
-                <a:spcPts val="1000"/>
-              </a:spcAft>
-              <a:defRPr sz="1200" b="0">
-                <a:solidFill>
-                  <a:srgbClr val="59636D"/>
-                </a:solidFill>
+            <a:r>
+              <a:rPr sz="1200">
                 <a:latin typeface="Arial"/>
-              </a:defRPr>
-            </a:pPr>
-            <a:r>
-              <a:t>12</a:t>
+              </a:rPr>
+              <a:t>14</a:t>
             </a:r>
           </a:p>
         </p:txBody>
@@ -7028,19 +7280,11 @@
           </a:bodyPr>
           <a:lstStyle/>
           <a:p>
-            <a:pPr>
-              <a:spcAft>
-                <a:spcPts val="1000"/>
-              </a:spcAft>
-              <a:defRPr sz="1200" b="0">
-                <a:solidFill>
-                  <a:srgbClr val="59636D"/>
-                </a:solidFill>
+            <a:r>
+              <a:rPr sz="1200">
                 <a:latin typeface="Arial"/>
-              </a:defRPr>
-            </a:pPr>
-            <a:r>
-              <a:t>13</a:t>
+              </a:rPr>
+              <a:t>15</a:t>
             </a:r>
           </a:p>
         </p:txBody>
@@ -7406,19 +7650,11 @@
           </a:bodyPr>
           <a:lstStyle/>
           <a:p>
-            <a:pPr>
-              <a:spcAft>
-                <a:spcPts val="1000"/>
-              </a:spcAft>
-              <a:defRPr sz="1200" b="0">
-                <a:solidFill>
-                  <a:srgbClr val="59636D"/>
-                </a:solidFill>
+            <a:r>
+              <a:rPr sz="1200">
                 <a:latin typeface="Arial"/>
-              </a:defRPr>
-            </a:pPr>
-            <a:r>
-              <a:t>14</a:t>
+              </a:rPr>
+              <a:t>16</a:t>
             </a:r>
           </a:p>
         </p:txBody>
@@ -7989,19 +8225,11 @@
           </a:bodyPr>
           <a:lstStyle/>
           <a:p>
-            <a:pPr>
-              <a:spcAft>
-                <a:spcPts val="1000"/>
-              </a:spcAft>
-              <a:defRPr sz="1200" b="0">
-                <a:solidFill>
-                  <a:srgbClr val="59636D"/>
-                </a:solidFill>
+            <a:r>
+              <a:rPr sz="1200">
                 <a:latin typeface="Arial"/>
-              </a:defRPr>
-            </a:pPr>
-            <a:r>
-              <a:t>15</a:t>
+              </a:rPr>
+              <a:t>17</a:t>
             </a:r>
           </a:p>
         </p:txBody>
@@ -8514,19 +8742,11 @@
           </a:bodyPr>
           <a:lstStyle/>
           <a:p>
-            <a:pPr>
-              <a:spcAft>
-                <a:spcPts val="1000"/>
-              </a:spcAft>
-              <a:defRPr sz="1200" b="0">
-                <a:solidFill>
-                  <a:srgbClr val="59636D"/>
-                </a:solidFill>
+            <a:r>
+              <a:rPr sz="1200">
                 <a:latin typeface="Arial"/>
-              </a:defRPr>
-            </a:pPr>
-            <a:r>
-              <a:t>16</a:t>
+              </a:rPr>
+              <a:t>18</a:t>
             </a:r>
           </a:p>
         </p:txBody>
@@ -9008,19 +9228,11 @@
           </a:bodyPr>
           <a:lstStyle/>
           <a:p>
-            <a:pPr>
-              <a:spcAft>
-                <a:spcPts val="1000"/>
-              </a:spcAft>
-              <a:defRPr sz="1200" b="0">
-                <a:solidFill>
-                  <a:srgbClr val="59636D"/>
-                </a:solidFill>
+            <a:r>
+              <a:rPr sz="1200">
                 <a:latin typeface="Arial"/>
-              </a:defRPr>
-            </a:pPr>
-            <a:r>
-              <a:t>17</a:t>
+              </a:rPr>
+              <a:t>19</a:t>
             </a:r>
           </a:p>
         </p:txBody>
@@ -9462,19 +9674,11 @@
           </a:bodyPr>
           <a:lstStyle/>
           <a:p>
-            <a:pPr>
-              <a:spcAft>
-                <a:spcPts val="1000"/>
-              </a:spcAft>
-              <a:defRPr sz="1200" b="0">
-                <a:solidFill>
-                  <a:srgbClr val="59636D"/>
-                </a:solidFill>
+            <a:r>
+              <a:rPr sz="1200">
                 <a:latin typeface="Arial"/>
-              </a:defRPr>
-            </a:pPr>
-            <a:r>
-              <a:t>18</a:t>
+              </a:rPr>
+              <a:t>20</a:t>
             </a:r>
           </a:p>
         </p:txBody>
@@ -9952,19 +10156,11 @@
           </a:bodyPr>
           <a:lstStyle/>
           <a:p>
-            <a:pPr>
-              <a:spcAft>
-                <a:spcPts val="1000"/>
-              </a:spcAft>
-              <a:defRPr sz="1200" b="0">
-                <a:solidFill>
-                  <a:srgbClr val="59636D"/>
-                </a:solidFill>
+            <a:r>
+              <a:rPr sz="1200">
                 <a:latin typeface="Arial"/>
-              </a:defRPr>
-            </a:pPr>
-            <a:r>
-              <a:t>19</a:t>
+              </a:rPr>
+              <a:t>21</a:t>
             </a:r>
           </a:p>
         </p:txBody>
@@ -10446,18 +10642,10 @@
           </a:bodyPr>
           <a:lstStyle/>
           <a:p>
-            <a:pPr>
-              <a:spcAft>
-                <a:spcPts val="1000"/>
-              </a:spcAft>
-              <a:defRPr sz="1200" b="0">
-                <a:solidFill>
-                  <a:srgbClr val="59636D"/>
-                </a:solidFill>
+            <a:r>
+              <a:rPr sz="1200">
                 <a:latin typeface="Arial"/>
-              </a:defRPr>
-            </a:pPr>
-            <a:r>
+              </a:rPr>
               <a:t>2</a:t>
             </a:r>
           </a:p>
@@ -10994,19 +11182,11 @@
           </a:bodyPr>
           <a:lstStyle/>
           <a:p>
-            <a:pPr>
-              <a:spcAft>
-                <a:spcPts val="1000"/>
-              </a:spcAft>
-              <a:defRPr sz="1200" b="0">
-                <a:solidFill>
-                  <a:srgbClr val="59636D"/>
-                </a:solidFill>
+            <a:r>
+              <a:rPr sz="1200">
                 <a:latin typeface="Arial"/>
-              </a:defRPr>
-            </a:pPr>
-            <a:r>
-              <a:t>20</a:t>
+              </a:rPr>
+              <a:t>22</a:t>
             </a:r>
           </a:p>
         </p:txBody>
@@ -11566,19 +11746,11 @@
           </a:bodyPr>
           <a:lstStyle/>
           <a:p>
-            <a:pPr>
-              <a:spcAft>
-                <a:spcPts val="1000"/>
-              </a:spcAft>
-              <a:defRPr sz="1200" b="0">
-                <a:solidFill>
-                  <a:srgbClr val="59636D"/>
-                </a:solidFill>
+            <a:r>
+              <a:rPr sz="1200">
                 <a:latin typeface="Arial"/>
-              </a:defRPr>
-            </a:pPr>
-            <a:r>
-              <a:t>21</a:t>
+              </a:rPr>
+              <a:t>23</a:t>
             </a:r>
           </a:p>
         </p:txBody>
@@ -12056,19 +12228,11 @@
           </a:bodyPr>
           <a:lstStyle/>
           <a:p>
-            <a:pPr>
-              <a:spcAft>
-                <a:spcPts val="1000"/>
-              </a:spcAft>
-              <a:defRPr sz="1200" b="0">
-                <a:solidFill>
-                  <a:srgbClr val="59636D"/>
-                </a:solidFill>
+            <a:r>
+              <a:rPr sz="1200">
                 <a:latin typeface="Arial"/>
-              </a:defRPr>
-            </a:pPr>
-            <a:r>
-              <a:t>22</a:t>
+              </a:rPr>
+              <a:t>24</a:t>
             </a:r>
           </a:p>
         </p:txBody>
@@ -12585,19 +12749,11 @@
           </a:bodyPr>
           <a:lstStyle/>
           <a:p>
-            <a:pPr>
-              <a:spcAft>
-                <a:spcPts val="1000"/>
-              </a:spcAft>
-              <a:defRPr sz="1200" b="0">
-                <a:solidFill>
-                  <a:srgbClr val="59636D"/>
-                </a:solidFill>
+            <a:r>
+              <a:rPr sz="1200">
                 <a:latin typeface="Arial"/>
-              </a:defRPr>
-            </a:pPr>
-            <a:r>
-              <a:t>23</a:t>
+              </a:rPr>
+              <a:t>27</a:t>
             </a:r>
           </a:p>
         </p:txBody>
@@ -12909,7 +13065,7 @@
               </a:defRPr>
             </a:pPr>
             <a:r>
-              <a:t>Báo cáo: reports/revised_main/</a:t>
+              <a:t>Báo cáo đúng mẫu PTIT: reports/ptit_verified/</a:t>
             </a:r>
           </a:p>
         </p:txBody>
@@ -12949,6 +13105,1642 @@
             </a:pPr>
             <a:r>
               <a:t>github.com/lequangduccode/tpour-trpo-experiments</a:t>
+            </a:r>
+          </a:p>
+        </p:txBody>
+      </p:sp>
+    </p:spTree>
+  </p:cSld>
+  <p:clrMapOvr>
+    <a:masterClrMapping/>
+  </p:clrMapOvr>
+</p:sld>
+</file>
+
+<file path=ppt/slides/slide24.xml><?xml version="1.0" encoding="utf-8"?>
+<p:sld xmlns:a="http://schemas.openxmlformats.org/drawingml/2006/main" xmlns:p="http://schemas.openxmlformats.org/presentationml/2006/main" xmlns:r="http://schemas.openxmlformats.org/officeDocument/2006/relationships">
+  <p:cSld>
+    <p:spTree>
+      <p:nvGrpSpPr>
+        <p:cNvPr id="1" name=""/>
+        <p:cNvGrpSpPr/>
+        <p:nvPr/>
+      </p:nvGrpSpPr>
+      <p:grpSpPr/>
+      <p:sp>
+        <p:nvSpPr>
+          <p:cNvPr id="2" name="Rectangle 1"/>
+          <p:cNvSpPr/>
+          <p:nvPr/>
+        </p:nvSpPr>
+        <p:spPr>
+          <a:xfrm>
+            <a:off x="502920" y="457200"/>
+            <a:ext cx="73152" cy="457200"/>
+          </a:xfrm>
+          <a:prstGeom prst="rect">
+            <a:avLst/>
+          </a:prstGeom>
+          <a:solidFill>
+            <a:srgbClr val="233E57"/>
+          </a:solidFill>
+          <a:ln>
+            <a:noFill/>
+          </a:ln>
+        </p:spPr>
+        <p:style>
+          <a:lnRef idx="1">
+            <a:schemeClr val="accent1"/>
+          </a:lnRef>
+          <a:fillRef idx="3">
+            <a:schemeClr val="accent1"/>
+          </a:fillRef>
+          <a:effectRef idx="2">
+            <a:schemeClr val="accent1"/>
+          </a:effectRef>
+          <a:fontRef idx="minor">
+            <a:schemeClr val="lt1"/>
+          </a:fontRef>
+        </p:style>
+        <p:txBody>
+          <a:bodyPr rtlCol="0" anchor="ctr"/>
+          <a:lstStyle/>
+          <a:p>
+            <a:pPr algn="ctr"/>
+          </a:p>
+        </p:txBody>
+      </p:sp>
+      <p:sp>
+        <p:nvSpPr>
+          <p:cNvPr id="3" name="TextBox 2"/>
+          <p:cNvSpPr txBox="1"/>
+          <p:nvPr/>
+        </p:nvSpPr>
+        <p:spPr>
+          <a:xfrm>
+            <a:off x="731520" y="384048"/>
+            <a:ext cx="10789920" cy="777240"/>
+          </a:xfrm>
+          <a:prstGeom prst="rect">
+            <a:avLst/>
+          </a:prstGeom>
+          <a:noFill/>
+        </p:spPr>
+        <p:txBody>
+          <a:bodyPr wrap="square" lIns="27432" rIns="27432" tIns="18288" bIns="18288">
+            <a:spAutoFit/>
+          </a:bodyPr>
+          <a:lstStyle/>
+          <a:p>
+            <a:pPr>
+              <a:spcAft>
+                <a:spcPts val="1000"/>
+              </a:spcAft>
+              <a:defRPr sz="2900" b="1">
+                <a:solidFill>
+                  <a:srgbClr val="233E57"/>
+                </a:solidFill>
+                <a:latin typeface="Arial"/>
+              </a:defRPr>
+            </a:pPr>
+            <a:r>
+              <a:t>Công thức nền: CE và TRPO</a:t>
+            </a:r>
+          </a:p>
+        </p:txBody>
+      </p:sp>
+      <p:sp>
+        <p:nvSpPr>
+          <p:cNvPr id="4" name="TextBox 3"/>
+          <p:cNvSpPr txBox="1"/>
+          <p:nvPr/>
+        </p:nvSpPr>
+        <p:spPr>
+          <a:xfrm>
+            <a:off x="594360" y="6473952"/>
+            <a:ext cx="10698480" cy="228600"/>
+          </a:xfrm>
+          <a:prstGeom prst="rect">
+            <a:avLst/>
+          </a:prstGeom>
+          <a:noFill/>
+        </p:spPr>
+        <p:txBody>
+          <a:bodyPr wrap="square" lIns="27432" rIns="27432" tIns="18288" bIns="18288">
+            <a:spAutoFit/>
+          </a:bodyPr>
+          <a:lstStyle/>
+          <a:p>
+            <a:pPr>
+              <a:spcAft>
+                <a:spcPts val="1000"/>
+              </a:spcAft>
+              <a:defRPr sz="1000" b="0">
+                <a:solidFill>
+                  <a:srgbClr val="59636D"/>
+                </a:solidFill>
+                <a:latin typeface="Arial"/>
+              </a:defRPr>
+            </a:pPr>
+            <a:r>
+              <a:t>Bài TPOUR [1], phương trình (3)–(4) · tpour.py:trpo_loss và TPOUR.forward</a:t>
+            </a:r>
+          </a:p>
+        </p:txBody>
+      </p:sp>
+      <p:sp>
+        <p:nvSpPr>
+          <p:cNvPr id="5" name="TextBox 4"/>
+          <p:cNvSpPr txBox="1"/>
+          <p:nvPr/>
+        </p:nvSpPr>
+        <p:spPr>
+          <a:xfrm>
+            <a:off x="11201400" y="6437376"/>
+            <a:ext cx="457200" cy="274320"/>
+          </a:xfrm>
+          <a:prstGeom prst="rect">
+            <a:avLst/>
+          </a:prstGeom>
+          <a:noFill/>
+        </p:spPr>
+        <p:txBody>
+          <a:bodyPr wrap="square" lIns="27432" rIns="27432" tIns="18288" bIns="18288">
+            <a:spAutoFit/>
+          </a:bodyPr>
+          <a:lstStyle/>
+          <a:p>
+            <a:r>
+              <a:rPr sz="1200">
+                <a:latin typeface="Arial"/>
+              </a:rPr>
+              <a:t>4</a:t>
+            </a:r>
+          </a:p>
+        </p:txBody>
+      </p:sp>
+      <p:pic>
+        <p:nvPicPr>
+          <p:cNvPr id="6" name="Picture 5" descr="ce_formula.png"/>
+          <p:cNvPicPr>
+            <a:picLocks noChangeAspect="1"/>
+          </p:cNvPicPr>
+          <p:nvPr/>
+        </p:nvPicPr>
+        <p:blipFill>
+          <a:blip r:embed="rId3"/>
+          <a:stretch>
+            <a:fillRect/>
+          </a:stretch>
+        </p:blipFill>
+        <p:spPr>
+          <a:xfrm>
+            <a:off x="3624703" y="1325880"/>
+            <a:ext cx="4912112" cy="1143000"/>
+          </a:xfrm>
+          <a:prstGeom prst="rect">
+            <a:avLst/>
+          </a:prstGeom>
+        </p:spPr>
+      </p:pic>
+      <p:pic>
+        <p:nvPicPr>
+          <p:cNvPr id="7" name="Picture 6" descr="gap_formula.png"/>
+          <p:cNvPicPr>
+            <a:picLocks noChangeAspect="1"/>
+          </p:cNvPicPr>
+          <p:nvPr/>
+        </p:nvPicPr>
+        <p:blipFill>
+          <a:blip r:embed="rId4"/>
+          <a:stretch>
+            <a:fillRect/>
+          </a:stretch>
+        </p:blipFill>
+        <p:spPr>
+          <a:xfrm>
+            <a:off x="4073325" y="2743200"/>
+            <a:ext cx="4014869" cy="822960"/>
+          </a:xfrm>
+          <a:prstGeom prst="rect">
+            <a:avLst/>
+          </a:prstGeom>
+        </p:spPr>
+      </p:pic>
+      <p:pic>
+        <p:nvPicPr>
+          <p:cNvPr id="8" name="Picture 7" descr="trpo_formula.png"/>
+          <p:cNvPicPr>
+            <a:picLocks noChangeAspect="1"/>
+          </p:cNvPicPr>
+          <p:nvPr/>
+        </p:nvPicPr>
+        <p:blipFill>
+          <a:blip r:embed="rId5"/>
+          <a:stretch>
+            <a:fillRect/>
+          </a:stretch>
+        </p:blipFill>
+        <p:spPr>
+          <a:xfrm>
+            <a:off x="3558963" y="3931920"/>
+            <a:ext cx="5043593" cy="1051560"/>
+          </a:xfrm>
+          <a:prstGeom prst="rect">
+            <a:avLst/>
+          </a:prstGeom>
+        </p:spPr>
+      </p:pic>
+      <p:sp>
+        <p:nvSpPr>
+          <p:cNvPr id="9" name="Rectangle 8"/>
+          <p:cNvSpPr/>
+          <p:nvPr/>
+        </p:nvSpPr>
+        <p:spPr>
+          <a:xfrm>
+            <a:off x="731520" y="5806440"/>
+            <a:ext cx="10698480" cy="475488"/>
+          </a:xfrm>
+          <a:prstGeom prst="rect">
+            <a:avLst/>
+          </a:prstGeom>
+          <a:solidFill>
+            <a:srgbClr val="EEF2F4"/>
+          </a:solidFill>
+          <a:ln>
+            <a:noFill/>
+          </a:ln>
+        </p:spPr>
+        <p:style>
+          <a:lnRef idx="1">
+            <a:schemeClr val="accent1"/>
+          </a:lnRef>
+          <a:fillRef idx="3">
+            <a:schemeClr val="accent1"/>
+          </a:fillRef>
+          <a:effectRef idx="2">
+            <a:schemeClr val="accent1"/>
+          </a:effectRef>
+          <a:fontRef idx="minor">
+            <a:schemeClr val="lt1"/>
+          </a:fontRef>
+        </p:style>
+        <p:txBody>
+          <a:bodyPr rtlCol="0" anchor="ctr"/>
+          <a:lstStyle/>
+          <a:p>
+            <a:pPr algn="ctr"/>
+          </a:p>
+        </p:txBody>
+      </p:sp>
+      <p:sp>
+        <p:nvSpPr>
+          <p:cNvPr id="10" name="TextBox 9"/>
+          <p:cNvSpPr txBox="1"/>
+          <p:nvPr/>
+        </p:nvSpPr>
+        <p:spPr>
+          <a:xfrm>
+            <a:off x="914400" y="5861303"/>
+            <a:ext cx="10332720" cy="384048"/>
+          </a:xfrm>
+          <a:prstGeom prst="rect">
+            <a:avLst/>
+          </a:prstGeom>
+          <a:noFill/>
+        </p:spPr>
+        <p:txBody>
+          <a:bodyPr wrap="square" lIns="27432" rIns="27432" tIns="18288" bIns="18288">
+            <a:spAutoFit/>
+          </a:bodyPr>
+          <a:lstStyle/>
+          <a:p>
+            <a:pPr>
+              <a:spcAft>
+                <a:spcPts val="1000"/>
+              </a:spcAft>
+              <a:defRPr sz="1800" b="1">
+                <a:solidFill>
+                  <a:srgbClr val="233E57"/>
+                </a:solidFill>
+                <a:latin typeface="Arial"/>
+              </a:defRPr>
+            </a:pPr>
+            <a:r>
+              <a:t>s(Q,D) là dot product; T=0,05; reference không nhận gradient trực tiếp.</a:t>
+            </a:r>
+          </a:p>
+        </p:txBody>
+      </p:sp>
+    </p:spTree>
+  </p:cSld>
+  <p:clrMapOvr>
+    <a:masterClrMapping/>
+  </p:clrMapOvr>
+</p:sld>
+</file>
+
+<file path=ppt/slides/slide25.xml><?xml version="1.0" encoding="utf-8"?>
+<p:sld xmlns:a="http://schemas.openxmlformats.org/drawingml/2006/main" xmlns:p="http://schemas.openxmlformats.org/presentationml/2006/main" xmlns:r="http://schemas.openxmlformats.org/officeDocument/2006/relationships">
+  <p:cSld>
+    <p:spTree>
+      <p:nvGrpSpPr>
+        <p:cNvPr id="1" name=""/>
+        <p:cNvGrpSpPr/>
+        <p:nvPr/>
+      </p:nvGrpSpPr>
+      <p:grpSpPr/>
+      <p:sp>
+        <p:nvSpPr>
+          <p:cNvPr id="2" name="Rectangle 1"/>
+          <p:cNvSpPr/>
+          <p:nvPr/>
+        </p:nvSpPr>
+        <p:spPr>
+          <a:xfrm>
+            <a:off x="502920" y="457200"/>
+            <a:ext cx="73152" cy="457200"/>
+          </a:xfrm>
+          <a:prstGeom prst="rect">
+            <a:avLst/>
+          </a:prstGeom>
+          <a:solidFill>
+            <a:srgbClr val="233E57"/>
+          </a:solidFill>
+          <a:ln>
+            <a:noFill/>
+          </a:ln>
+        </p:spPr>
+        <p:style>
+          <a:lnRef idx="1">
+            <a:schemeClr val="accent1"/>
+          </a:lnRef>
+          <a:fillRef idx="3">
+            <a:schemeClr val="accent1"/>
+          </a:fillRef>
+          <a:effectRef idx="2">
+            <a:schemeClr val="accent1"/>
+          </a:effectRef>
+          <a:fontRef idx="minor">
+            <a:schemeClr val="lt1"/>
+          </a:fontRef>
+        </p:style>
+        <p:txBody>
+          <a:bodyPr rtlCol="0" anchor="ctr"/>
+          <a:lstStyle/>
+          <a:p>
+            <a:pPr algn="ctr"/>
+          </a:p>
+        </p:txBody>
+      </p:sp>
+      <p:sp>
+        <p:nvSpPr>
+          <p:cNvPr id="3" name="TextBox 2"/>
+          <p:cNvSpPr txBox="1"/>
+          <p:nvPr/>
+        </p:nvSpPr>
+        <p:spPr>
+          <a:xfrm>
+            <a:off x="731520" y="384048"/>
+            <a:ext cx="10789920" cy="777240"/>
+          </a:xfrm>
+          <a:prstGeom prst="rect">
+            <a:avLst/>
+          </a:prstGeom>
+          <a:noFill/>
+        </p:spPr>
+        <p:txBody>
+          <a:bodyPr wrap="square" lIns="27432" rIns="27432" tIns="18288" bIns="18288">
+            <a:spAutoFit/>
+          </a:bodyPr>
+          <a:lstStyle/>
+          <a:p>
+            <a:pPr>
+              <a:spcAft>
+                <a:spcPts val="1000"/>
+              </a:spcAft>
+              <a:defRPr sz="2900" b="1">
+                <a:solidFill>
+                  <a:srgbClr val="233E57"/>
+                </a:solidFill>
+                <a:latin typeface="Arial"/>
+              </a:defRPr>
+            </a:pPr>
+            <a:r>
+              <a:t>Time vector: nội dung của bài báo, chưa tái lập đủ</a:t>
+            </a:r>
+          </a:p>
+        </p:txBody>
+      </p:sp>
+      <p:sp>
+        <p:nvSpPr>
+          <p:cNvPr id="4" name="TextBox 3"/>
+          <p:cNvSpPr txBox="1"/>
+          <p:nvPr/>
+        </p:nvSpPr>
+        <p:spPr>
+          <a:xfrm>
+            <a:off x="594360" y="6473952"/>
+            <a:ext cx="10698480" cy="228600"/>
+          </a:xfrm>
+          <a:prstGeom prst="rect">
+            <a:avLst/>
+          </a:prstGeom>
+          <a:noFill/>
+        </p:spPr>
+        <p:txBody>
+          <a:bodyPr wrap="square" lIns="27432" rIns="27432" tIns="18288" bIns="18288">
+            <a:spAutoFit/>
+          </a:bodyPr>
+          <a:lstStyle/>
+          <a:p>
+            <a:pPr>
+              <a:spcAft>
+                <a:spcPts val="1000"/>
+              </a:spcAft>
+              <a:defRPr sz="1000" b="0">
+                <a:solidFill>
+                  <a:srgbClr val="59636D"/>
+                </a:solidFill>
+                <a:latin typeface="Arial"/>
+              </a:defRPr>
+            </a:pPr>
+            <a:r>
+              <a:t>Bài TPOUR [1], mục 3.2, phương trình (5) · Báo cáo PTIT mục 2.6</a:t>
+            </a:r>
+          </a:p>
+        </p:txBody>
+      </p:sp>
+      <p:sp>
+        <p:nvSpPr>
+          <p:cNvPr id="5" name="TextBox 4"/>
+          <p:cNvSpPr txBox="1"/>
+          <p:nvPr/>
+        </p:nvSpPr>
+        <p:spPr>
+          <a:xfrm>
+            <a:off x="11201400" y="6437376"/>
+            <a:ext cx="457200" cy="274320"/>
+          </a:xfrm>
+          <a:prstGeom prst="rect">
+            <a:avLst/>
+          </a:prstGeom>
+          <a:noFill/>
+        </p:spPr>
+        <p:txBody>
+          <a:bodyPr wrap="square" lIns="27432" rIns="27432" tIns="18288" bIns="18288">
+            <a:spAutoFit/>
+          </a:bodyPr>
+          <a:lstStyle/>
+          <a:p>
+            <a:r>
+              <a:rPr sz="1200">
+                <a:latin typeface="Arial"/>
+              </a:rPr>
+              <a:t>5</a:t>
+            </a:r>
+          </a:p>
+        </p:txBody>
+      </p:sp>
+      <p:pic>
+        <p:nvPicPr>
+          <p:cNvPr id="6" name="Picture 5" descr="time_vector.png"/>
+          <p:cNvPicPr>
+            <a:picLocks noChangeAspect="1"/>
+          </p:cNvPicPr>
+          <p:nvPr/>
+        </p:nvPicPr>
+        <p:blipFill>
+          <a:blip r:embed="rId3"/>
+          <a:stretch>
+            <a:fillRect/>
+          </a:stretch>
+        </p:blipFill>
+        <p:spPr>
+          <a:xfrm>
+            <a:off x="4078452" y="1645920"/>
+            <a:ext cx="4004614" cy="868680"/>
+          </a:xfrm>
+          <a:prstGeom prst="rect">
+            <a:avLst/>
+          </a:prstGeom>
+        </p:spPr>
+      </p:pic>
+      <p:pic>
+        <p:nvPicPr>
+          <p:cNvPr id="7" name="Picture 6" descr="time_interpolation.png"/>
+          <p:cNvPicPr>
+            <a:picLocks noChangeAspect="1"/>
+          </p:cNvPicPr>
+          <p:nvPr/>
+        </p:nvPicPr>
+        <p:blipFill>
+          <a:blip r:embed="rId4"/>
+          <a:stretch>
+            <a:fillRect/>
+          </a:stretch>
+        </p:blipFill>
+        <p:spPr>
+          <a:xfrm>
+            <a:off x="1529926" y="2834640"/>
+            <a:ext cx="9101666" cy="914400"/>
+          </a:xfrm>
+          <a:prstGeom prst="rect">
+            <a:avLst/>
+          </a:prstGeom>
+        </p:spPr>
+      </p:pic>
+      <p:sp>
+        <p:nvSpPr>
+          <p:cNvPr id="8" name="TextBox 7"/>
+          <p:cNvSpPr txBox="1"/>
+          <p:nvPr/>
+        </p:nvSpPr>
+        <p:spPr>
+          <a:xfrm>
+            <a:off x="914400" y="4389120"/>
+            <a:ext cx="10332720" cy="777240"/>
+          </a:xfrm>
+          <a:prstGeom prst="rect">
+            <a:avLst/>
+          </a:prstGeom>
+          <a:noFill/>
+        </p:spPr>
+        <p:txBody>
+          <a:bodyPr wrap="square" lIns="27432" rIns="27432" tIns="18288" bIns="18288">
+            <a:spAutoFit/>
+          </a:bodyPr>
+          <a:lstStyle/>
+          <a:p>
+            <a:pPr>
+              <a:spcAft>
+                <a:spcPts val="1000"/>
+              </a:spcAft>
+              <a:defRPr sz="2400" b="0">
+                <a:solidFill>
+                  <a:srgbClr val="202A32"/>
+                </a:solidFill>
+                <a:latin typeface="Arial"/>
+              </a:defRPr>
+            </a:pPr>
+            <a:r>
+              <a:t>Hai checkpoint phải cùng nền; đổi encoder cần mã hóa lại corpus.</a:t>
+            </a:r>
+          </a:p>
+        </p:txBody>
+      </p:sp>
+      <p:sp>
+        <p:nvSpPr>
+          <p:cNvPr id="9" name="Rectangle 8"/>
+          <p:cNvSpPr/>
+          <p:nvPr/>
+        </p:nvSpPr>
+        <p:spPr>
+          <a:xfrm>
+            <a:off x="731520" y="5806440"/>
+            <a:ext cx="10698480" cy="475488"/>
+          </a:xfrm>
+          <a:prstGeom prst="rect">
+            <a:avLst/>
+          </a:prstGeom>
+          <a:solidFill>
+            <a:srgbClr val="EEF2F4"/>
+          </a:solidFill>
+          <a:ln>
+            <a:noFill/>
+          </a:ln>
+        </p:spPr>
+        <p:style>
+          <a:lnRef idx="1">
+            <a:schemeClr val="accent1"/>
+          </a:lnRef>
+          <a:fillRef idx="3">
+            <a:schemeClr val="accent1"/>
+          </a:fillRef>
+          <a:effectRef idx="2">
+            <a:schemeClr val="accent1"/>
+          </a:effectRef>
+          <a:fontRef idx="minor">
+            <a:schemeClr val="lt1"/>
+          </a:fontRef>
+        </p:style>
+        <p:txBody>
+          <a:bodyPr rtlCol="0" anchor="ctr"/>
+          <a:lstStyle/>
+          <a:p>
+            <a:pPr algn="ctr"/>
+          </a:p>
+        </p:txBody>
+      </p:sp>
+      <p:sp>
+        <p:nvSpPr>
+          <p:cNvPr id="10" name="TextBox 9"/>
+          <p:cNvSpPr txBox="1"/>
+          <p:nvPr/>
+        </p:nvSpPr>
+        <p:spPr>
+          <a:xfrm>
+            <a:off x="914400" y="5861303"/>
+            <a:ext cx="10332720" cy="384048"/>
+          </a:xfrm>
+          <a:prstGeom prst="rect">
+            <a:avLst/>
+          </a:prstGeom>
+          <a:noFill/>
+        </p:spPr>
+        <p:txBody>
+          <a:bodyPr wrap="square" lIns="27432" rIns="27432" tIns="18288" bIns="18288">
+            <a:spAutoFit/>
+          </a:bodyPr>
+          <a:lstStyle/>
+          <a:p>
+            <a:pPr>
+              <a:spcAft>
+                <a:spcPts val="1000"/>
+              </a:spcAft>
+              <a:defRPr sz="1800" b="1">
+                <a:solidFill>
+                  <a:srgbClr val="233E57"/>
+                </a:solidFill>
+                <a:latin typeface="Arial"/>
+              </a:defRPr>
+            </a:pPr>
+            <a:r>
+              <a:t>Đã có kiểm tra phép nội suy tensor; chưa có kết quả temporal interpolation thật.</a:t>
+            </a:r>
+          </a:p>
+        </p:txBody>
+      </p:sp>
+    </p:spTree>
+  </p:cSld>
+  <p:clrMapOvr>
+    <a:masterClrMapping/>
+  </p:clrMapOvr>
+</p:sld>
+</file>
+
+<file path=ppt/slides/slide26.xml><?xml version="1.0" encoding="utf-8"?>
+<p:sld xmlns:a="http://schemas.openxmlformats.org/drawingml/2006/main" xmlns:p="http://schemas.openxmlformats.org/presentationml/2006/main" xmlns:r="http://schemas.openxmlformats.org/officeDocument/2006/relationships">
+  <p:cSld>
+    <p:spTree>
+      <p:nvGrpSpPr>
+        <p:cNvPr id="1" name=""/>
+        <p:cNvGrpSpPr/>
+        <p:nvPr/>
+      </p:nvGrpSpPr>
+      <p:grpSpPr/>
+      <p:sp>
+        <p:nvSpPr>
+          <p:cNvPr id="2" name="Rectangle 1"/>
+          <p:cNvSpPr/>
+          <p:nvPr/>
+        </p:nvSpPr>
+        <p:spPr>
+          <a:xfrm>
+            <a:off x="502920" y="457200"/>
+            <a:ext cx="73152" cy="457200"/>
+          </a:xfrm>
+          <a:prstGeom prst="rect">
+            <a:avLst/>
+          </a:prstGeom>
+          <a:solidFill>
+            <a:srgbClr val="233E57"/>
+          </a:solidFill>
+          <a:ln>
+            <a:noFill/>
+          </a:ln>
+        </p:spPr>
+        <p:style>
+          <a:lnRef idx="1">
+            <a:schemeClr val="accent1"/>
+          </a:lnRef>
+          <a:fillRef idx="3">
+            <a:schemeClr val="accent1"/>
+          </a:fillRef>
+          <a:effectRef idx="2">
+            <a:schemeClr val="accent1"/>
+          </a:effectRef>
+          <a:fontRef idx="minor">
+            <a:schemeClr val="lt1"/>
+          </a:fontRef>
+        </p:style>
+        <p:txBody>
+          <a:bodyPr rtlCol="0" anchor="ctr"/>
+          <a:lstStyle/>
+          <a:p>
+            <a:pPr algn="ctr"/>
+          </a:p>
+        </p:txBody>
+      </p:sp>
+      <p:sp>
+        <p:nvSpPr>
+          <p:cNvPr id="3" name="TextBox 2"/>
+          <p:cNvSpPr txBox="1"/>
+          <p:nvPr/>
+        </p:nvSpPr>
+        <p:spPr>
+          <a:xfrm>
+            <a:off x="731520" y="384048"/>
+            <a:ext cx="10789920" cy="777240"/>
+          </a:xfrm>
+          <a:prstGeom prst="rect">
+            <a:avLst/>
+          </a:prstGeom>
+          <a:noFill/>
+        </p:spPr>
+        <p:txBody>
+          <a:bodyPr wrap="square" lIns="27432" rIns="27432" tIns="18288" bIns="18288">
+            <a:spAutoFit/>
+          </a:bodyPr>
+          <a:lstStyle/>
+          <a:p>
+            <a:pPr>
+              <a:spcAft>
+                <a:spcPts val="1000"/>
+              </a:spcAft>
+              <a:defRPr sz="2900" b="1">
+                <a:solidFill>
+                  <a:srgbClr val="233E57"/>
+                </a:solidFill>
+                <a:latin typeface="Arial"/>
+              </a:defRPr>
+            </a:pPr>
+            <a:r>
+              <a:t>Hỏi đáp · KL và relative MSE tính trên gì?</a:t>
+            </a:r>
+          </a:p>
+        </p:txBody>
+      </p:sp>
+      <p:sp>
+        <p:nvSpPr>
+          <p:cNvPr id="4" name="TextBox 3"/>
+          <p:cNvSpPr txBox="1"/>
+          <p:nvPr/>
+        </p:nvSpPr>
+        <p:spPr>
+          <a:xfrm>
+            <a:off x="594360" y="6473952"/>
+            <a:ext cx="10698480" cy="228600"/>
+          </a:xfrm>
+          <a:prstGeom prst="rect">
+            <a:avLst/>
+          </a:prstGeom>
+          <a:noFill/>
+        </p:spPr>
+        <p:txBody>
+          <a:bodyPr wrap="square" lIns="27432" rIns="27432" tIns="18288" bIns="18288">
+            <a:spAutoFit/>
+          </a:bodyPr>
+          <a:lstStyle/>
+          <a:p>
+            <a:pPr>
+              <a:spcAft>
+                <a:spcPts val="1000"/>
+              </a:spcAft>
+              <a:defRPr sz="1000" b="0">
+                <a:solidFill>
+                  <a:srgbClr val="59636D"/>
+                </a:solidFill>
+                <a:latin typeface="Arial"/>
+              </a:defRPr>
+            </a:pPr>
+            <a:r>
+              <a:t>anchored_tpour.py:retention_loss · Báo cáo PTIT mục 3.4</a:t>
+            </a:r>
+          </a:p>
+        </p:txBody>
+      </p:sp>
+      <p:sp>
+        <p:nvSpPr>
+          <p:cNvPr id="5" name="TextBox 4"/>
+          <p:cNvSpPr txBox="1"/>
+          <p:nvPr/>
+        </p:nvSpPr>
+        <p:spPr>
+          <a:xfrm>
+            <a:off x="11201400" y="6437376"/>
+            <a:ext cx="457200" cy="274320"/>
+          </a:xfrm>
+          <a:prstGeom prst="rect">
+            <a:avLst/>
+          </a:prstGeom>
+          <a:noFill/>
+        </p:spPr>
+        <p:txBody>
+          <a:bodyPr wrap="square" lIns="27432" rIns="27432" tIns="18288" bIns="18288">
+            <a:spAutoFit/>
+          </a:bodyPr>
+          <a:lstStyle/>
+          <a:p>
+            <a:r>
+              <a:rPr sz="1200">
+                <a:latin typeface="Arial"/>
+              </a:rPr>
+              <a:t>25</a:t>
+            </a:r>
+          </a:p>
+        </p:txBody>
+      </p:sp>
+      <p:pic>
+        <p:nvPicPr>
+          <p:cNvPr id="6" name="Picture 5" descr="distribution.png"/>
+          <p:cNvPicPr>
+            <a:picLocks noChangeAspect="1"/>
+          </p:cNvPicPr>
+          <p:nvPr/>
+        </p:nvPicPr>
+        <p:blipFill>
+          <a:blip r:embed="rId3"/>
+          <a:stretch>
+            <a:fillRect/>
+          </a:stretch>
+        </p:blipFill>
+        <p:spPr>
+          <a:xfrm>
+            <a:off x="4329625" y="1325880"/>
+            <a:ext cx="3502269" cy="1143000"/>
+          </a:xfrm>
+          <a:prstGeom prst="rect">
+            <a:avLst/>
+          </a:prstGeom>
+        </p:spPr>
+      </p:pic>
+      <p:pic>
+        <p:nvPicPr>
+          <p:cNvPr id="7" name="Picture 6" descr="kl_formula.png"/>
+          <p:cNvPicPr>
+            <a:picLocks noChangeAspect="1"/>
+          </p:cNvPicPr>
+          <p:nvPr/>
+        </p:nvPicPr>
+        <p:blipFill>
+          <a:blip r:embed="rId4"/>
+          <a:stretch>
+            <a:fillRect/>
+          </a:stretch>
+        </p:blipFill>
+        <p:spPr>
+          <a:xfrm>
+            <a:off x="4636008" y="2788920"/>
+            <a:ext cx="2889504" cy="914400"/>
+          </a:xfrm>
+          <a:prstGeom prst="rect">
+            <a:avLst/>
+          </a:prstGeom>
+        </p:spPr>
+      </p:pic>
+      <p:pic>
+        <p:nvPicPr>
+          <p:cNvPr id="8" name="Picture 7" descr="mse_formula.png"/>
+          <p:cNvPicPr>
+            <a:picLocks noChangeAspect="1"/>
+          </p:cNvPicPr>
+          <p:nvPr/>
+        </p:nvPicPr>
+        <p:blipFill>
+          <a:blip r:embed="rId5"/>
+          <a:stretch>
+            <a:fillRect/>
+          </a:stretch>
+        </p:blipFill>
+        <p:spPr>
+          <a:xfrm>
+            <a:off x="4074557" y="4069080"/>
+            <a:ext cx="4012404" cy="1051560"/>
+          </a:xfrm>
+          <a:prstGeom prst="rect">
+            <a:avLst/>
+          </a:prstGeom>
+        </p:spPr>
+      </p:pic>
+      <p:sp>
+        <p:nvSpPr>
+          <p:cNvPr id="9" name="Rectangle 8"/>
+          <p:cNvSpPr/>
+          <p:nvPr/>
+        </p:nvSpPr>
+        <p:spPr>
+          <a:xfrm>
+            <a:off x="731520" y="5806440"/>
+            <a:ext cx="10698480" cy="475488"/>
+          </a:xfrm>
+          <a:prstGeom prst="rect">
+            <a:avLst/>
+          </a:prstGeom>
+          <a:solidFill>
+            <a:srgbClr val="EEF2F4"/>
+          </a:solidFill>
+          <a:ln>
+            <a:noFill/>
+          </a:ln>
+        </p:spPr>
+        <p:style>
+          <a:lnRef idx="1">
+            <a:schemeClr val="accent1"/>
+          </a:lnRef>
+          <a:fillRef idx="3">
+            <a:schemeClr val="accent1"/>
+          </a:fillRef>
+          <a:effectRef idx="2">
+            <a:schemeClr val="accent1"/>
+          </a:effectRef>
+          <a:fontRef idx="minor">
+            <a:schemeClr val="lt1"/>
+          </a:fontRef>
+        </p:style>
+        <p:txBody>
+          <a:bodyPr rtlCol="0" anchor="ctr"/>
+          <a:lstStyle/>
+          <a:p>
+            <a:pPr algn="ctr"/>
+          </a:p>
+        </p:txBody>
+      </p:sp>
+      <p:sp>
+        <p:nvSpPr>
+          <p:cNvPr id="10" name="TextBox 9"/>
+          <p:cNvSpPr txBox="1"/>
+          <p:nvPr/>
+        </p:nvSpPr>
+        <p:spPr>
+          <a:xfrm>
+            <a:off x="914400" y="5861303"/>
+            <a:ext cx="10332720" cy="384048"/>
+          </a:xfrm>
+          <a:prstGeom prst="rect">
+            <a:avLst/>
+          </a:prstGeom>
+          <a:noFill/>
+        </p:spPr>
+        <p:txBody>
+          <a:bodyPr wrap="square" lIns="27432" rIns="27432" tIns="18288" bIns="18288">
+            <a:spAutoFit/>
+          </a:bodyPr>
+          <a:lstStyle/>
+          <a:p>
+            <a:pPr>
+              <a:spcAft>
+                <a:spcPts val="1000"/>
+              </a:spcAft>
+              <a:defRPr sz="1800" b="1">
+                <a:solidFill>
+                  <a:srgbClr val="233E57"/>
+                </a:solidFill>
+                <a:latin typeface="Arial"/>
+              </a:defRPr>
+            </a:pPr>
+            <a:r>
+              <a:t>a∈{student, teacher}; B=4; Tr=0,1. Teacher targets được detach.</a:t>
+            </a:r>
+          </a:p>
+        </p:txBody>
+      </p:sp>
+    </p:spTree>
+  </p:cSld>
+  <p:clrMapOvr>
+    <a:masterClrMapping/>
+  </p:clrMapOvr>
+</p:sld>
+</file>
+
+<file path=ppt/slides/slide27.xml><?xml version="1.0" encoding="utf-8"?>
+<p:sld xmlns:a="http://schemas.openxmlformats.org/drawingml/2006/main" xmlns:p="http://schemas.openxmlformats.org/presentationml/2006/main" xmlns:r="http://schemas.openxmlformats.org/officeDocument/2006/relationships">
+  <p:cSld>
+    <p:spTree>
+      <p:nvGrpSpPr>
+        <p:cNvPr id="1" name=""/>
+        <p:cNvGrpSpPr/>
+        <p:nvPr/>
+      </p:nvGrpSpPr>
+      <p:grpSpPr/>
+      <p:sp>
+        <p:nvSpPr>
+          <p:cNvPr id="2" name="Rectangle 1"/>
+          <p:cNvSpPr/>
+          <p:nvPr/>
+        </p:nvSpPr>
+        <p:spPr>
+          <a:xfrm>
+            <a:off x="502920" y="457200"/>
+            <a:ext cx="73152" cy="457200"/>
+          </a:xfrm>
+          <a:prstGeom prst="rect">
+            <a:avLst/>
+          </a:prstGeom>
+          <a:solidFill>
+            <a:srgbClr val="233E57"/>
+          </a:solidFill>
+          <a:ln>
+            <a:noFill/>
+          </a:ln>
+        </p:spPr>
+        <p:style>
+          <a:lnRef idx="1">
+            <a:schemeClr val="accent1"/>
+          </a:lnRef>
+          <a:fillRef idx="3">
+            <a:schemeClr val="accent1"/>
+          </a:fillRef>
+          <a:effectRef idx="2">
+            <a:schemeClr val="accent1"/>
+          </a:effectRef>
+          <a:fontRef idx="minor">
+            <a:schemeClr val="lt1"/>
+          </a:fontRef>
+        </p:style>
+        <p:txBody>
+          <a:bodyPr rtlCol="0" anchor="ctr"/>
+          <a:lstStyle/>
+          <a:p>
+            <a:pPr algn="ctr"/>
+          </a:p>
+        </p:txBody>
+      </p:sp>
+      <p:sp>
+        <p:nvSpPr>
+          <p:cNvPr id="3" name="TextBox 2"/>
+          <p:cNvSpPr txBox="1"/>
+          <p:nvPr/>
+        </p:nvSpPr>
+        <p:spPr>
+          <a:xfrm>
+            <a:off x="731520" y="384048"/>
+            <a:ext cx="10789920" cy="777240"/>
+          </a:xfrm>
+          <a:prstGeom prst="rect">
+            <a:avLst/>
+          </a:prstGeom>
+          <a:noFill/>
+        </p:spPr>
+        <p:txBody>
+          <a:bodyPr wrap="square" lIns="27432" rIns="27432" tIns="18288" bIns="18288">
+            <a:spAutoFit/>
+          </a:bodyPr>
+          <a:lstStyle/>
+          <a:p>
+            <a:pPr>
+              <a:spcAft>
+                <a:spcPts val="1000"/>
+              </a:spcAft>
+              <a:defRPr sz="2900" b="1">
+                <a:solidFill>
+                  <a:srgbClr val="233E57"/>
+                </a:solidFill>
+                <a:latin typeface="Arial"/>
+              </a:defRPr>
+            </a:pPr>
+            <a:r>
+              <a:t>Hỏi đáp · Có dùng context ngoài vào train không?</a:t>
+            </a:r>
+          </a:p>
+        </p:txBody>
+      </p:sp>
+      <p:sp>
+        <p:nvSpPr>
+          <p:cNvPr id="4" name="TextBox 3"/>
+          <p:cNvSpPr txBox="1"/>
+          <p:nvPr/>
+        </p:nvSpPr>
+        <p:spPr>
+          <a:xfrm>
+            <a:off x="594360" y="6473952"/>
+            <a:ext cx="10698480" cy="228600"/>
+          </a:xfrm>
+          <a:prstGeom prst="rect">
+            <a:avLst/>
+          </a:prstGeom>
+          <a:noFill/>
+        </p:spPr>
+        <p:txBody>
+          <a:bodyPr wrap="square" lIns="27432" rIns="27432" tIns="18288" bIns="18288">
+            <a:spAutoFit/>
+          </a:bodyPr>
+          <a:lstStyle/>
+          <a:p>
+            <a:pPr>
+              <a:spcAft>
+                <a:spcPts val="1000"/>
+              </a:spcAft>
+              <a:defRPr sz="1000" b="0">
+                <a:solidFill>
+                  <a:srgbClr val="59636D"/>
+                </a:solidFill>
+                <a:latin typeface="Arial"/>
+              </a:defRPr>
+            </a:pPr>
+            <a:r>
+              <a:t>real_experiment.py:clean_rows/train · live_retrieval_demo.py · data_manifest.json</a:t>
+            </a:r>
+          </a:p>
+        </p:txBody>
+      </p:sp>
+      <p:sp>
+        <p:nvSpPr>
+          <p:cNvPr id="5" name="TextBox 4"/>
+          <p:cNvSpPr txBox="1"/>
+          <p:nvPr/>
+        </p:nvSpPr>
+        <p:spPr>
+          <a:xfrm>
+            <a:off x="11201400" y="6437376"/>
+            <a:ext cx="457200" cy="274320"/>
+          </a:xfrm>
+          <a:prstGeom prst="rect">
+            <a:avLst/>
+          </a:prstGeom>
+          <a:noFill/>
+        </p:spPr>
+        <p:txBody>
+          <a:bodyPr wrap="square" lIns="27432" rIns="27432" tIns="18288" bIns="18288">
+            <a:spAutoFit/>
+          </a:bodyPr>
+          <a:lstStyle/>
+          <a:p>
+            <a:r>
+              <a:rPr sz="1200">
+                <a:latin typeface="Arial"/>
+              </a:rPr>
+              <a:t>26</a:t>
+            </a:r>
+          </a:p>
+        </p:txBody>
+      </p:sp>
+      <p:graphicFrame>
+        <p:nvGraphicFramePr>
+          <p:cNvPr id="6" name="Table 5"/>
+          <p:cNvGraphicFramePr>
+            <a:graphicFrameLocks noGrp="1"/>
+          </p:cNvGraphicFramePr>
+          <p:nvPr/>
+        </p:nvGraphicFramePr>
+        <p:xfrm>
+          <a:off x="777240" y="1554480"/>
+          <a:ext cx="10607040" cy="3657600"/>
+        </p:xfrm>
+        <a:graphic>
+          <a:graphicData uri="http://schemas.openxmlformats.org/drawingml/2006/table">
+            <a:tbl>
+              <a:tblPr firstRow="1" bandRow="1">
+                <a:tableStyleId>{5C22544A-7EE6-4342-B048-85BDC9FD1C3A}</a:tableStyleId>
+              </a:tblPr>
+              <a:tblGrid>
+                <a:gridCol w="3200400"/>
+                <a:gridCol w="4206240"/>
+                <a:gridCol w="3200400"/>
+              </a:tblGrid>
+              <a:tr h="731520">
+                <a:tc>
+                  <a:txBody>
+                    <a:bodyPr/>
+                    <a:lstStyle/>
+                    <a:p>
+                      <a:pPr>
+                        <a:defRPr sz="2200" b="1">
+                          <a:solidFill>
+                            <a:srgbClr val="FFFFFF"/>
+                          </a:solidFill>
+                          <a:latin typeface="Arial"/>
+                        </a:defRPr>
+                      </a:pPr>
+                      <a:r>
+                        <a:t>Nguồn</a:t>
+                      </a:r>
+                    </a:p>
+                  </a:txBody>
+                  <a:tcPr marL="109728" marT="82296">
+                    <a:solidFill>
+                      <a:srgbClr val="233E57"/>
+                    </a:solidFill>
+                  </a:tcPr>
+                </a:tc>
+                <a:tc>
+                  <a:txBody>
+                    <a:bodyPr/>
+                    <a:lstStyle/>
+                    <a:p>
+                      <a:pPr>
+                        <a:defRPr sz="2200" b="1">
+                          <a:solidFill>
+                            <a:srgbClr val="FFFFFF"/>
+                          </a:solidFill>
+                          <a:latin typeface="Arial"/>
+                        </a:defRPr>
+                      </a:pPr>
+                      <a:r>
+                        <a:t>Vai trò</a:t>
+                      </a:r>
+                    </a:p>
+                  </a:txBody>
+                  <a:tcPr marL="109728" marT="82296">
+                    <a:solidFill>
+                      <a:srgbClr val="233E57"/>
+                    </a:solidFill>
+                  </a:tcPr>
+                </a:tc>
+                <a:tc>
+                  <a:txBody>
+                    <a:bodyPr/>
+                    <a:lstStyle/>
+                    <a:p>
+                      <a:pPr>
+                        <a:defRPr sz="2200" b="1">
+                          <a:solidFill>
+                            <a:srgbClr val="FFFFFF"/>
+                          </a:solidFill>
+                          <a:latin typeface="Arial"/>
+                        </a:defRPr>
+                      </a:pPr>
+                      <a:r>
+                        <a:t>Có cập nhật gradient?</a:t>
+                      </a:r>
+                    </a:p>
+                  </a:txBody>
+                  <a:tcPr marL="109728" marT="82296">
+                    <a:solidFill>
+                      <a:srgbClr val="233E57"/>
+                    </a:solidFill>
+                  </a:tcPr>
+                </a:tc>
+              </a:tr>
+              <a:tr h="731520">
+                <a:tc>
+                  <a:txBody>
+                    <a:bodyPr/>
+                    <a:lstStyle/>
+                    <a:p>
+                      <a:pPr>
+                        <a:defRPr sz="2200" b="0">
+                          <a:solidFill>
+                            <a:srgbClr val="202A32"/>
+                          </a:solidFill>
+                          <a:latin typeface="Arial"/>
+                        </a:defRPr>
+                      </a:pPr>
+                      <a:r>
+                        <a:t>Mẫu Wikipedia tác giả</a:t>
+                      </a:r>
+                    </a:p>
+                  </a:txBody>
+                  <a:tcPr marL="109728" marT="82296">
+                    <a:solidFill>
+                      <a:srgbClr val="F0F3F5"/>
+                    </a:solidFill>
+                  </a:tcPr>
+                </a:tc>
+                <a:tc>
+                  <a:txBody>
+                    <a:bodyPr/>
+                    <a:lstStyle/>
+                    <a:p>
+                      <a:pPr>
+                        <a:defRPr sz="2200" b="0">
+                          <a:solidFill>
+                            <a:srgbClr val="202A32"/>
+                          </a:solidFill>
+                          <a:latin typeface="Arial"/>
+                        </a:defRPr>
+                      </a:pPr>
+                      <a:r>
+                        <a:t>Train split 2.543 bộ ba</a:t>
+                      </a:r>
+                    </a:p>
+                  </a:txBody>
+                  <a:tcPr marL="109728" marT="82296">
+                    <a:solidFill>
+                      <a:srgbClr val="F0F3F5"/>
+                    </a:solidFill>
+                  </a:tcPr>
+                </a:tc>
+                <a:tc>
+                  <a:txBody>
+                    <a:bodyPr/>
+                    <a:lstStyle/>
+                    <a:p>
+                      <a:pPr>
+                        <a:defRPr sz="2200" b="0">
+                          <a:solidFill>
+                            <a:srgbClr val="202A32"/>
+                          </a:solidFill>
+                          <a:latin typeface="Arial"/>
+                        </a:defRPr>
+                      </a:pPr>
+                      <a:r>
+                        <a:t>Có</a:t>
+                      </a:r>
+                    </a:p>
+                  </a:txBody>
+                  <a:tcPr marL="109728" marT="82296">
+                    <a:solidFill>
+                      <a:srgbClr val="F0F3F5"/>
+                    </a:solidFill>
+                  </a:tcPr>
+                </a:tc>
+              </a:tr>
+              <a:tr h="731520">
+                <a:tc>
+                  <a:txBody>
+                    <a:bodyPr/>
+                    <a:lstStyle/>
+                    <a:p>
+                      <a:pPr>
+                        <a:defRPr sz="2200" b="0">
+                          <a:solidFill>
+                            <a:srgbClr val="202A32"/>
+                          </a:solidFill>
+                          <a:latin typeface="Arial"/>
+                        </a:defRPr>
+                      </a:pPr>
+                      <a:r>
+                        <a:t>Held-out mined</a:t>
+                      </a:r>
+                    </a:p>
+                  </a:txBody>
+                  <a:tcPr marL="109728" marT="82296">
+                    <a:solidFill>
+                      <a:srgbClr val="FFFFFF"/>
+                    </a:solidFill>
+                  </a:tcPr>
+                </a:tc>
+                <a:tc>
+                  <a:txBody>
+                    <a:bodyPr/>
+                    <a:lstStyle/>
+                    <a:p>
+                      <a:pPr>
+                        <a:defRPr sz="2200" b="0">
+                          <a:solidFill>
+                            <a:srgbClr val="202A32"/>
+                          </a:solidFill>
+                          <a:latin typeface="Arial"/>
+                        </a:defRPr>
+                      </a:pPr>
+                      <a:r>
+                        <a:t>449 bộ ba đo proxy</a:t>
+                      </a:r>
+                    </a:p>
+                  </a:txBody>
+                  <a:tcPr marL="109728" marT="82296">
+                    <a:solidFill>
+                      <a:srgbClr val="FFFFFF"/>
+                    </a:solidFill>
+                  </a:tcPr>
+                </a:tc>
+                <a:tc>
+                  <a:txBody>
+                    <a:bodyPr/>
+                    <a:lstStyle/>
+                    <a:p>
+                      <a:pPr>
+                        <a:defRPr sz="2200" b="0">
+                          <a:solidFill>
+                            <a:srgbClr val="202A32"/>
+                          </a:solidFill>
+                          <a:latin typeface="Arial"/>
+                        </a:defRPr>
+                      </a:pPr>
+                      <a:r>
+                        <a:t>Không</a:t>
+                      </a:r>
+                    </a:p>
+                  </a:txBody>
+                  <a:tcPr marL="109728" marT="82296">
+                    <a:solidFill>
+                      <a:srgbClr val="FFFFFF"/>
+                    </a:solidFill>
+                  </a:tcPr>
+                </a:tc>
+              </a:tr>
+              <a:tr h="731520">
+                <a:tc>
+                  <a:txBody>
+                    <a:bodyPr/>
+                    <a:lstStyle/>
+                    <a:p>
+                      <a:pPr>
+                        <a:defRPr sz="2200" b="0">
+                          <a:solidFill>
+                            <a:srgbClr val="202A32"/>
+                          </a:solidFill>
+                          <a:latin typeface="Arial"/>
+                        </a:defRPr>
+                      </a:pPr>
+                      <a:r>
+                        <a:t>SciFact / qrels</a:t>
+                      </a:r>
+                    </a:p>
+                  </a:txBody>
+                  <a:tcPr marL="109728" marT="82296">
+                    <a:solidFill>
+                      <a:srgbClr val="F0F3F5"/>
+                    </a:solidFill>
+                  </a:tcPr>
+                </a:tc>
+                <a:tc>
+                  <a:txBody>
+                    <a:bodyPr/>
+                    <a:lstStyle/>
+                    <a:p>
+                      <a:pPr>
+                        <a:defRPr sz="2200" b="0">
+                          <a:solidFill>
+                            <a:srgbClr val="202A32"/>
+                          </a:solidFill>
+                          <a:latin typeface="Arial"/>
+                        </a:defRPr>
+                      </a:pPr>
+                      <a:r>
+                        <a:t>Đánh giá và truy xuất demo</a:t>
+                      </a:r>
+                    </a:p>
+                  </a:txBody>
+                  <a:tcPr marL="109728" marT="82296">
+                    <a:solidFill>
+                      <a:srgbClr val="F0F3F5"/>
+                    </a:solidFill>
+                  </a:tcPr>
+                </a:tc>
+                <a:tc>
+                  <a:txBody>
+                    <a:bodyPr/>
+                    <a:lstStyle/>
+                    <a:p>
+                      <a:pPr>
+                        <a:defRPr sz="2200" b="0">
+                          <a:solidFill>
+                            <a:srgbClr val="202A32"/>
+                          </a:solidFill>
+                          <a:latin typeface="Arial"/>
+                        </a:defRPr>
+                      </a:pPr>
+                      <a:r>
+                        <a:t>Không</a:t>
+                      </a:r>
+                    </a:p>
+                  </a:txBody>
+                  <a:tcPr marL="109728" marT="82296">
+                    <a:solidFill>
+                      <a:srgbClr val="F0F3F5"/>
+                    </a:solidFill>
+                  </a:tcPr>
+                </a:tc>
+              </a:tr>
+              <a:tr h="731520">
+                <a:tc>
+                  <a:txBody>
+                    <a:bodyPr/>
+                    <a:lstStyle/>
+                    <a:p>
+                      <a:pPr>
+                        <a:defRPr sz="2200" b="0">
+                          <a:solidFill>
+                            <a:srgbClr val="202A32"/>
+                          </a:solidFill>
+                          <a:latin typeface="Arial"/>
+                        </a:defRPr>
+                      </a:pPr>
+                      <a:r>
+                        <a:t>Contriever tiền huấn luyện</a:t>
+                      </a:r>
+                    </a:p>
+                  </a:txBody>
+                  <a:tcPr marL="109728" marT="82296">
+                    <a:solidFill>
+                      <a:srgbClr val="FFFFFF"/>
+                    </a:solidFill>
+                  </a:tcPr>
+                </a:tc>
+                <a:tc>
+                  <a:txBody>
+                    <a:bodyPr/>
+                    <a:lstStyle/>
+                    <a:p>
+                      <a:pPr>
+                        <a:defRPr sz="2200" b="0">
+                          <a:solidFill>
+                            <a:srgbClr val="202A32"/>
+                          </a:solidFill>
+                          <a:latin typeface="Arial"/>
+                        </a:defRPr>
+                      </a:pPr>
+                      <a:r>
+                        <a:t>Khởi tạo model / teacher</a:t>
+                      </a:r>
+                    </a:p>
+                  </a:txBody>
+                  <a:tcPr marL="109728" marT="82296">
+                    <a:solidFill>
+                      <a:srgbClr val="FFFFFF"/>
+                    </a:solidFill>
+                  </a:tcPr>
+                </a:tc>
+                <a:tc>
+                  <a:txBody>
+                    <a:bodyPr/>
+                    <a:lstStyle/>
+                    <a:p>
+                      <a:pPr>
+                        <a:defRPr sz="2200" b="0">
+                          <a:solidFill>
+                            <a:srgbClr val="202A32"/>
+                          </a:solidFill>
+                          <a:latin typeface="Arial"/>
+                        </a:defRPr>
+                      </a:pPr>
+                      <a:r>
+                        <a:t>Student được fine-tune</a:t>
+                      </a:r>
+                    </a:p>
+                  </a:txBody>
+                  <a:tcPr marL="109728" marT="82296">
+                    <a:solidFill>
+                      <a:srgbClr val="FFFFFF"/>
+                    </a:solidFill>
+                  </a:tcPr>
+                </a:tc>
+              </a:tr>
+            </a:tbl>
+          </a:graphicData>
+        </a:graphic>
+      </p:graphicFrame>
+      <p:sp>
+        <p:nvSpPr>
+          <p:cNvPr id="7" name="Rectangle 6"/>
+          <p:cNvSpPr/>
+          <p:nvPr/>
+        </p:nvSpPr>
+        <p:spPr>
+          <a:xfrm>
+            <a:off x="731520" y="5806440"/>
+            <a:ext cx="10698480" cy="475488"/>
+          </a:xfrm>
+          <a:prstGeom prst="rect">
+            <a:avLst/>
+          </a:prstGeom>
+          <a:solidFill>
+            <a:srgbClr val="EEF2F4"/>
+          </a:solidFill>
+          <a:ln>
+            <a:noFill/>
+          </a:ln>
+        </p:spPr>
+        <p:style>
+          <a:lnRef idx="1">
+            <a:schemeClr val="accent1"/>
+          </a:lnRef>
+          <a:fillRef idx="3">
+            <a:schemeClr val="accent1"/>
+          </a:fillRef>
+          <a:effectRef idx="2">
+            <a:schemeClr val="accent1"/>
+          </a:effectRef>
+          <a:fontRef idx="minor">
+            <a:schemeClr val="lt1"/>
+          </a:fontRef>
+        </p:style>
+        <p:txBody>
+          <a:bodyPr rtlCol="0" anchor="ctr"/>
+          <a:lstStyle/>
+          <a:p>
+            <a:pPr algn="ctr"/>
+          </a:p>
+        </p:txBody>
+      </p:sp>
+      <p:sp>
+        <p:nvSpPr>
+          <p:cNvPr id="8" name="TextBox 7"/>
+          <p:cNvSpPr txBox="1"/>
+          <p:nvPr/>
+        </p:nvSpPr>
+        <p:spPr>
+          <a:xfrm>
+            <a:off x="914400" y="5861303"/>
+            <a:ext cx="10332720" cy="384048"/>
+          </a:xfrm>
+          <a:prstGeom prst="rect">
+            <a:avLst/>
+          </a:prstGeom>
+          <a:noFill/>
+        </p:spPr>
+        <p:txBody>
+          <a:bodyPr wrap="square" lIns="27432" rIns="27432" tIns="18288" bIns="18288">
+            <a:spAutoFit/>
+          </a:bodyPr>
+          <a:lstStyle/>
+          <a:p>
+            <a:pPr>
+              <a:spcAft>
+                <a:spcPts val="1000"/>
+              </a:spcAft>
+              <a:defRPr sz="1800" b="1">
+                <a:solidFill>
+                  <a:srgbClr val="233E57"/>
+                </a:solidFill>
+                <a:latin typeface="Arial"/>
+              </a:defRPr>
+            </a:pPr>
+            <a:r>
+              <a:t>Không thấy bước gọi web/LLM để bổ sung context trong pipeline đã chạy.</a:t>
             </a:r>
           </a:p>
         </p:txBody>
@@ -13114,18 +14906,10 @@
           </a:bodyPr>
           <a:lstStyle/>
           <a:p>
-            <a:pPr>
-              <a:spcAft>
-                <a:spcPts val="1000"/>
-              </a:spcAft>
-              <a:defRPr sz="1200" b="0">
-                <a:solidFill>
-                  <a:srgbClr val="59636D"/>
-                </a:solidFill>
+            <a:r>
+              <a:rPr sz="1200">
                 <a:latin typeface="Arial"/>
-              </a:defRPr>
-            </a:pPr>
-            <a:r>
+              </a:rPr>
               <a:t>3</a:t>
             </a:r>
           </a:p>
@@ -13686,19 +15470,11 @@
           </a:bodyPr>
           <a:lstStyle/>
           <a:p>
-            <a:pPr>
-              <a:spcAft>
-                <a:spcPts val="1000"/>
-              </a:spcAft>
-              <a:defRPr sz="1200" b="0">
-                <a:solidFill>
-                  <a:srgbClr val="59636D"/>
-                </a:solidFill>
+            <a:r>
+              <a:rPr sz="1200">
                 <a:latin typeface="Arial"/>
-              </a:defRPr>
-            </a:pPr>
-            <a:r>
-              <a:t>4</a:t>
+              </a:rPr>
+              <a:t>6</a:t>
             </a:r>
           </a:p>
         </p:txBody>
@@ -14140,19 +15916,11 @@
           </a:bodyPr>
           <a:lstStyle/>
           <a:p>
-            <a:pPr>
-              <a:spcAft>
-                <a:spcPts val="1000"/>
-              </a:spcAft>
-              <a:defRPr sz="1200" b="0">
-                <a:solidFill>
-                  <a:srgbClr val="59636D"/>
-                </a:solidFill>
+            <a:r>
+              <a:rPr sz="1200">
                 <a:latin typeface="Arial"/>
-              </a:defRPr>
-            </a:pPr>
-            <a:r>
-              <a:t>5</a:t>
+              </a:rPr>
+              <a:t>7</a:t>
             </a:r>
           </a:p>
         </p:txBody>
@@ -14797,19 +16565,11 @@
           </a:bodyPr>
           <a:lstStyle/>
           <a:p>
-            <a:pPr>
-              <a:spcAft>
-                <a:spcPts val="1000"/>
-              </a:spcAft>
-              <a:defRPr sz="1200" b="0">
-                <a:solidFill>
-                  <a:srgbClr val="59636D"/>
-                </a:solidFill>
+            <a:r>
+              <a:rPr sz="1200">
                 <a:latin typeface="Arial"/>
-              </a:defRPr>
-            </a:pPr>
-            <a:r>
-              <a:t>6</a:t>
+              </a:rPr>
+              <a:t>8</a:t>
             </a:r>
           </a:p>
         </p:txBody>
@@ -15507,19 +17267,11 @@
           </a:bodyPr>
           <a:lstStyle/>
           <a:p>
-            <a:pPr>
-              <a:spcAft>
-                <a:spcPts val="1000"/>
-              </a:spcAft>
-              <a:defRPr sz="1200" b="0">
-                <a:solidFill>
-                  <a:srgbClr val="59636D"/>
-                </a:solidFill>
+            <a:r>
+              <a:rPr sz="1200">
                 <a:latin typeface="Arial"/>
-              </a:defRPr>
-            </a:pPr>
-            <a:r>
-              <a:t>7</a:t>
+              </a:rPr>
+              <a:t>9</a:t>
             </a:r>
           </a:p>
         </p:txBody>
@@ -16001,19 +17753,11 @@
           </a:bodyPr>
           <a:lstStyle/>
           <a:p>
-            <a:pPr>
-              <a:spcAft>
-                <a:spcPts val="1000"/>
-              </a:spcAft>
-              <a:defRPr sz="1200" b="0">
-                <a:solidFill>
-                  <a:srgbClr val="59636D"/>
-                </a:solidFill>
+            <a:r>
+              <a:rPr sz="1200">
                 <a:latin typeface="Arial"/>
-              </a:defRPr>
-            </a:pPr>
-            <a:r>
-              <a:t>8</a:t>
+              </a:rPr>
+              <a:t>10</a:t>
             </a:r>
           </a:p>
         </p:txBody>
@@ -16534,19 +18278,11 @@
           </a:bodyPr>
           <a:lstStyle/>
           <a:p>
-            <a:pPr>
-              <a:spcAft>
-                <a:spcPts val="1000"/>
-              </a:spcAft>
-              <a:defRPr sz="1200" b="0">
-                <a:solidFill>
-                  <a:srgbClr val="59636D"/>
-                </a:solidFill>
+            <a:r>
+              <a:rPr sz="1200">
                 <a:latin typeface="Arial"/>
-              </a:defRPr>
-            </a:pPr>
-            <a:r>
-              <a:t>9</a:t>
+              </a:rPr>
+              <a:t>11</a:t>
             </a:r>
           </a:p>
         </p:txBody>

</xml_diff>